<commit_message>
feat(release): prepare VectorDeckPPT v1.1.0
Improve staged deck approvals, compiler fidelity, path safety, documentation, examples, dependency installation, and automated GitHub release publishing.
</commit_message>
<xml_diff>
--- a/examples/basic-deck/example.pptx
+++ b/examples/basic-deck/example.pptx
@@ -3231,7 +3231,7 @@
               </a:spcAft>
             </a:pPr>
             <a:r>
-              <a:rPr sz="5850" b="1" i="0">
+              <a:rPr sz="4680" b="1" i="0">
                 <a:solidFill>
                   <a:srgbClr val="0F172A"/>
                 </a:solidFill>
@@ -3273,7 +3273,7 @@
               </a:spcAft>
             </a:pPr>
             <a:r>
-              <a:rPr sz="2400" b="0" i="0">
+              <a:rPr sz="1920" b="0" i="0">
                 <a:solidFill>
                   <a:srgbClr val="475569"/>
                 </a:solidFill>
@@ -3315,7 +3315,7 @@
               </a:spcAft>
             </a:pPr>
             <a:r>
-              <a:rPr sz="1800" b="0" i="0">
+              <a:rPr sz="1440" b="0" i="0">
                 <a:solidFill>
                   <a:srgbClr val="475569"/>
                 </a:solidFill>
@@ -3357,7 +3357,7 @@
               </a:spcAft>
             </a:pPr>
             <a:r>
-              <a:rPr sz="1425" b="0" i="0">
+              <a:rPr sz="1139" b="0" i="0">
                 <a:solidFill>
                   <a:srgbClr val="94A3B8"/>
                 </a:solidFill>
@@ -3399,7 +3399,7 @@
               </a:spcAft>
             </a:pPr>
             <a:r>
-              <a:rPr sz="1350" b="0" i="0">
+              <a:rPr sz="1080" b="0" i="0">
                 <a:solidFill>
                   <a:srgbClr val="94A3B8"/>
                 </a:solidFill>
@@ -3488,7 +3488,7 @@
               </a:spcAft>
             </a:pPr>
             <a:r>
-              <a:rPr sz="3900" b="1" i="0">
+              <a:rPr sz="3120" b="1" i="0">
                 <a:solidFill>
                   <a:srgbClr val="0F172A"/>
                 </a:solidFill>
@@ -3530,7 +3530,7 @@
               </a:spcAft>
             </a:pPr>
             <a:r>
-              <a:rPr sz="1725" b="0" i="0">
+              <a:rPr sz="1380" b="0" i="0">
                 <a:solidFill>
                   <a:srgbClr val="475569"/>
                 </a:solidFill>
@@ -3776,7 +3776,7 @@
               </a:spcAft>
             </a:pPr>
             <a:r>
-              <a:rPr sz="2550" b="1" i="0">
+              <a:rPr sz="2039" b="1" i="0">
                 <a:solidFill>
                   <a:srgbClr val="FFFFFF"/>
                 </a:solidFill>
@@ -3818,7 +3818,7 @@
               </a:spcAft>
             </a:pPr>
             <a:r>
-              <a:rPr sz="2550" b="1" i="0">
+              <a:rPr sz="2039" b="1" i="0">
                 <a:solidFill>
                   <a:srgbClr val="2563EB"/>
                 </a:solidFill>
@@ -3860,7 +3860,7 @@
               </a:spcAft>
             </a:pPr>
             <a:r>
-              <a:rPr sz="2550" b="1" i="0">
+              <a:rPr sz="2039" b="1" i="0">
                 <a:solidFill>
                   <a:srgbClr val="2563EB"/>
                 </a:solidFill>
@@ -3902,7 +3902,7 @@
               </a:spcAft>
             </a:pPr>
             <a:r>
-              <a:rPr sz="2550" b="1" i="0">
+              <a:rPr sz="2039" b="1" i="0">
                 <a:solidFill>
                   <a:srgbClr val="FFFFFF"/>
                 </a:solidFill>
@@ -3944,7 +3944,7 @@
               </a:spcAft>
             </a:pPr>
             <a:r>
-              <a:rPr sz="2250" b="1" i="0">
+              <a:rPr sz="1800" b="1" i="0">
                 <a:solidFill>
                   <a:srgbClr val="0F172A"/>
                 </a:solidFill>
@@ -3986,7 +3986,7 @@
               </a:spcAft>
             </a:pPr>
             <a:r>
-              <a:rPr sz="1500" b="0" i="0">
+              <a:rPr sz="1200" b="0" i="0">
                 <a:solidFill>
                   <a:srgbClr val="64748B"/>
                 </a:solidFill>
@@ -4028,7 +4028,7 @@
               </a:spcAft>
             </a:pPr>
             <a:r>
-              <a:rPr sz="2250" b="1" i="0">
+              <a:rPr sz="1800" b="1" i="0">
                 <a:solidFill>
                   <a:srgbClr val="0F172A"/>
                 </a:solidFill>
@@ -4070,7 +4070,7 @@
               </a:spcAft>
             </a:pPr>
             <a:r>
-              <a:rPr sz="1500" b="0" i="0">
+              <a:rPr sz="1200" b="0" i="0">
                 <a:solidFill>
                   <a:srgbClr val="64748B"/>
                 </a:solidFill>
@@ -4112,7 +4112,7 @@
               </a:spcAft>
             </a:pPr>
             <a:r>
-              <a:rPr sz="2250" b="1" i="0">
+              <a:rPr sz="1800" b="1" i="0">
                 <a:solidFill>
                   <a:srgbClr val="0F172A"/>
                 </a:solidFill>
@@ -4154,7 +4154,7 @@
               </a:spcAft>
             </a:pPr>
             <a:r>
-              <a:rPr sz="1500" b="0" i="0">
+              <a:rPr sz="1200" b="0" i="0">
                 <a:solidFill>
                   <a:srgbClr val="64748B"/>
                 </a:solidFill>
@@ -4196,7 +4196,7 @@
               </a:spcAft>
             </a:pPr>
             <a:r>
-              <a:rPr sz="2250" b="1" i="0">
+              <a:rPr sz="1800" b="1" i="0">
                 <a:solidFill>
                   <a:srgbClr val="0F172A"/>
                 </a:solidFill>
@@ -4238,7 +4238,7 @@
               </a:spcAft>
             </a:pPr>
             <a:r>
-              <a:rPr sz="1500" b="0" i="0">
+              <a:rPr sz="1200" b="0" i="0">
                 <a:solidFill>
                   <a:srgbClr val="64748B"/>
                 </a:solidFill>
@@ -4280,7 +4280,7 @@
               </a:spcAft>
             </a:pPr>
             <a:r>
-              <a:rPr sz="1350" b="0" i="0">
+              <a:rPr sz="1080" b="0" i="0">
                 <a:solidFill>
                   <a:srgbClr val="94A3B8"/>
                 </a:solidFill>
@@ -4369,7 +4369,7 @@
               </a:spcAft>
             </a:pPr>
             <a:r>
-              <a:rPr sz="3900" b="1" i="0">
+              <a:rPr sz="3120" b="1" i="0">
                 <a:solidFill>
                   <a:srgbClr val="0F172A"/>
                 </a:solidFill>
@@ -4411,7 +4411,7 @@
               </a:spcAft>
             </a:pPr>
             <a:r>
-              <a:rPr sz="1725" b="0" i="0">
+              <a:rPr sz="1380" b="0" i="0">
                 <a:solidFill>
                   <a:srgbClr val="475569"/>
                 </a:solidFill>
@@ -4503,7 +4503,7 @@
               </a:spcAft>
             </a:pPr>
             <a:r>
-              <a:rPr sz="2250" b="1" i="0">
+              <a:rPr sz="1800" b="1" i="0">
                 <a:solidFill>
                   <a:srgbClr val="0F172A"/>
                 </a:solidFill>
@@ -4545,7 +4545,7 @@
               </a:spcAft>
             </a:pPr>
             <a:r>
-              <a:rPr sz="1875" b="0" i="0">
+              <a:rPr sz="1500" b="0" i="0">
                 <a:solidFill>
                   <a:srgbClr val="334155"/>
                 </a:solidFill>
@@ -4587,7 +4587,7 @@
               </a:spcAft>
             </a:pPr>
             <a:r>
-              <a:rPr sz="1875" b="0" i="0">
+              <a:rPr sz="1500" b="0" i="0">
                 <a:solidFill>
                   <a:srgbClr val="334155"/>
                 </a:solidFill>
@@ -4629,7 +4629,7 @@
               </a:spcAft>
             </a:pPr>
             <a:r>
-              <a:rPr sz="1875" b="0" i="0">
+              <a:rPr sz="1500" b="0" i="0">
                 <a:solidFill>
                   <a:srgbClr val="334155"/>
                 </a:solidFill>
@@ -4704,7 +4704,7 @@
               </a:spcAft>
             </a:pPr>
             <a:r>
-              <a:rPr sz="1800" b="0" i="0">
+              <a:rPr sz="1440" b="0" i="0">
                 <a:solidFill>
                   <a:srgbClr val="1D4ED8"/>
                 </a:solidFill>
@@ -4831,7 +4831,7 @@
               </a:spcAft>
             </a:pPr>
             <a:r>
-              <a:rPr sz="1650" b="0" i="0">
+              <a:rPr sz="1320" b="0" i="0">
                 <a:solidFill>
                   <a:srgbClr val="64748B"/>
                 </a:solidFill>
@@ -4902,7 +4902,7 @@
               </a:spcAft>
             </a:pPr>
             <a:r>
-              <a:rPr sz="2250" b="1" i="0">
+              <a:rPr sz="1800" b="1" i="0">
                 <a:solidFill>
                   <a:srgbClr val="0F172A"/>
                 </a:solidFill>
@@ -4944,7 +4944,7 @@
               </a:spcAft>
             </a:pPr>
             <a:r>
-              <a:rPr sz="1950" b="1" i="0">
+              <a:rPr sz="1560" b="1" i="0">
                 <a:solidFill>
                   <a:srgbClr val="334155"/>
                 </a:solidFill>
@@ -5019,7 +5019,7 @@
               </a:spcAft>
             </a:pPr>
             <a:r>
-              <a:rPr sz="1725" b="0" i="0">
+              <a:rPr sz="1380" b="0" i="0">
                 <a:solidFill>
                   <a:srgbClr val="6D28D9"/>
                 </a:solidFill>
@@ -5061,7 +5061,7 @@
               </a:spcAft>
             </a:pPr>
             <a:r>
-              <a:rPr sz="1350" b="0" i="0">
+              <a:rPr sz="1080" b="0" i="0">
                 <a:solidFill>
                   <a:srgbClr val="7C3AED"/>
                 </a:solidFill>
@@ -5103,7 +5103,7 @@
               </a:spcAft>
             </a:pPr>
             <a:r>
-              <a:rPr sz="1650" b="0" i="0">
+              <a:rPr sz="1320" b="0" i="0">
                 <a:solidFill>
                   <a:srgbClr val="64748B"/>
                 </a:solidFill>
@@ -5145,7 +5145,7 @@
               </a:spcAft>
             </a:pPr>
             <a:r>
-              <a:rPr sz="1350" b="0" i="0">
+              <a:rPr sz="1080" b="0" i="0">
                 <a:solidFill>
                   <a:srgbClr val="94A3B8"/>
                 </a:solidFill>
@@ -5234,7 +5234,7 @@
               </a:spcAft>
             </a:pPr>
             <a:r>
-              <a:rPr sz="3900" b="1" i="0">
+              <a:rPr sz="3120" b="1" i="0">
                 <a:solidFill>
                   <a:srgbClr val="0F172A"/>
                 </a:solidFill>
@@ -5276,7 +5276,7 @@
               </a:spcAft>
             </a:pPr>
             <a:r>
-              <a:rPr sz="1725" b="0" i="0">
+              <a:rPr sz="1380" b="0" i="0">
                 <a:solidFill>
                   <a:srgbClr val="475569"/>
                 </a:solidFill>
@@ -5455,7 +5455,7 @@
               </a:spcAft>
             </a:pPr>
             <a:r>
-              <a:rPr sz="1875" b="1" i="0">
+              <a:rPr sz="1500" b="1" i="0">
                 <a:solidFill>
                   <a:srgbClr val="0F172A"/>
                 </a:solidFill>
@@ -5497,7 +5497,7 @@
               </a:spcAft>
             </a:pPr>
             <a:r>
-              <a:rPr sz="1875" b="1" i="0">
+              <a:rPr sz="1500" b="1" i="0">
                 <a:solidFill>
                   <a:srgbClr val="0F172A"/>
                 </a:solidFill>
@@ -5539,7 +5539,7 @@
               </a:spcAft>
             </a:pPr>
             <a:r>
-              <a:rPr sz="1875" b="1" i="0">
+              <a:rPr sz="1500" b="1" i="0">
                 <a:solidFill>
                   <a:srgbClr val="0F172A"/>
                 </a:solidFill>
@@ -5581,7 +5581,7 @@
               </a:spcAft>
             </a:pPr>
             <a:r>
-              <a:rPr sz="1875" b="1" i="0">
+              <a:rPr sz="1500" b="1" i="0">
                 <a:solidFill>
                   <a:srgbClr val="0F172A"/>
                 </a:solidFill>
@@ -5687,7 +5687,7 @@
               </a:spcAft>
             </a:pPr>
             <a:r>
-              <a:rPr sz="1800" b="1" i="0">
+              <a:rPr sz="1440" b="1" i="0">
                 <a:solidFill>
                   <a:srgbClr val="1D4ED8"/>
                 </a:solidFill>
@@ -5729,7 +5729,7 @@
               </a:spcAft>
             </a:pPr>
             <a:r>
-              <a:rPr sz="1650" b="0" i="0">
+              <a:rPr sz="1320" b="0" i="0">
                 <a:solidFill>
                   <a:srgbClr val="334155"/>
                 </a:solidFill>
@@ -5771,7 +5771,7 @@
               </a:spcAft>
             </a:pPr>
             <a:r>
-              <a:rPr sz="1650" b="0" i="0">
+              <a:rPr sz="1320" b="0" i="0">
                 <a:solidFill>
                   <a:srgbClr val="334155"/>
                 </a:solidFill>
@@ -5813,7 +5813,7 @@
               </a:spcAft>
             </a:pPr>
             <a:r>
-              <a:rPr sz="1350" b="0" i="0">
+              <a:rPr sz="1080" b="0" i="0">
                 <a:solidFill>
                   <a:srgbClr val="64748B"/>
                 </a:solidFill>
@@ -5876,7 +5876,7 @@
               </a:spcAft>
             </a:pPr>
             <a:r>
-              <a:rPr sz="1800" b="1" i="0">
+              <a:rPr sz="1440" b="1" i="0">
                 <a:solidFill>
                   <a:srgbClr val="6D28D9"/>
                 </a:solidFill>
@@ -5918,7 +5918,7 @@
               </a:spcAft>
             </a:pPr>
             <a:r>
-              <a:rPr sz="1650" b="0" i="0">
+              <a:rPr sz="1320" b="0" i="0">
                 <a:solidFill>
                   <a:srgbClr val="334155"/>
                 </a:solidFill>
@@ -5960,7 +5960,7 @@
               </a:spcAft>
             </a:pPr>
             <a:r>
-              <a:rPr sz="1650" b="0" i="0">
+              <a:rPr sz="1320" b="0" i="0">
                 <a:solidFill>
                   <a:srgbClr val="334155"/>
                 </a:solidFill>
@@ -6002,7 +6002,7 @@
               </a:spcAft>
             </a:pPr>
             <a:r>
-              <a:rPr sz="1350" b="0" i="0">
+              <a:rPr sz="1080" b="0" i="0">
                 <a:solidFill>
                   <a:srgbClr val="64748B"/>
                 </a:solidFill>
@@ -6044,7 +6044,7 @@
               </a:spcAft>
             </a:pPr>
             <a:r>
-              <a:rPr sz="1350" b="0" i="0">
+              <a:rPr sz="1080" b="0" i="0">
                 <a:solidFill>
                   <a:srgbClr val="94A3B8"/>
                 </a:solidFill>
@@ -6195,7 +6195,7 @@
               </a:spcAft>
             </a:pPr>
             <a:r>
-              <a:rPr sz="2250" b="0" i="0">
+              <a:rPr sz="1800" b="0" i="0">
                 <a:solidFill>
                   <a:srgbClr val="93C5FD"/>
                 </a:solidFill>
@@ -6237,7 +6237,7 @@
               </a:spcAft>
             </a:pPr>
             <a:r>
-              <a:rPr sz="4800" b="1" i="0">
+              <a:rPr sz="3840" b="1" i="0">
                 <a:solidFill>
                   <a:srgbClr val="FFFFFF"/>
                 </a:solidFill>
@@ -6279,7 +6279,7 @@
               </a:spcAft>
             </a:pPr>
             <a:r>
-              <a:rPr sz="2025" b="0" i="0">
+              <a:rPr sz="1620" b="0" i="0">
                 <a:solidFill>
                   <a:srgbClr val="CBD5E1"/>
                 </a:solidFill>
@@ -6342,7 +6342,7 @@
               </a:spcAft>
             </a:pPr>
             <a:r>
-              <a:rPr sz="2100" b="1" i="0">
+              <a:rPr sz="1680" b="1" i="0">
                 <a:solidFill>
                   <a:srgbClr val="FFFFFF"/>
                 </a:solidFill>
@@ -6384,7 +6384,7 @@
               </a:spcAft>
             </a:pPr>
             <a:r>
-              <a:rPr sz="1500" b="0" i="0">
+              <a:rPr sz="1200" b="0" i="0">
                 <a:solidFill>
                   <a:srgbClr val="94A3B8"/>
                 </a:solidFill>
@@ -6426,7 +6426,7 @@
               </a:spcAft>
             </a:pPr>
             <a:r>
-              <a:rPr sz="2100" b="1" i="0">
+              <a:rPr sz="1680" b="1" i="0">
                 <a:solidFill>
                   <a:srgbClr val="FFFFFF"/>
                 </a:solidFill>
@@ -6468,7 +6468,7 @@
               </a:spcAft>
             </a:pPr>
             <a:r>
-              <a:rPr sz="1500" b="0" i="0">
+              <a:rPr sz="1200" b="0" i="0">
                 <a:solidFill>
                   <a:srgbClr val="94A3B8"/>
                 </a:solidFill>
@@ -6510,7 +6510,7 @@
               </a:spcAft>
             </a:pPr>
             <a:r>
-              <a:rPr sz="2100" b="1" i="0">
+              <a:rPr sz="1680" b="1" i="0">
                 <a:solidFill>
                   <a:srgbClr val="FFFFFF"/>
                 </a:solidFill>
@@ -6552,7 +6552,7 @@
               </a:spcAft>
             </a:pPr>
             <a:r>
-              <a:rPr sz="1500" b="0" i="0">
+              <a:rPr sz="1200" b="0" i="0">
                 <a:solidFill>
                   <a:srgbClr val="94A3B8"/>
                 </a:solidFill>
@@ -6594,7 +6594,7 @@
               </a:spcAft>
             </a:pPr>
             <a:r>
-              <a:rPr sz="2100" b="1" i="0">
+              <a:rPr sz="1680" b="1" i="0">
                 <a:solidFill>
                   <a:srgbClr val="FFFFFF"/>
                 </a:solidFill>
@@ -6636,7 +6636,7 @@
               </a:spcAft>
             </a:pPr>
             <a:r>
-              <a:rPr sz="1500" b="0" i="0">
+              <a:rPr sz="1200" b="0" i="0">
                 <a:solidFill>
                   <a:srgbClr val="94A3B8"/>
                 </a:solidFill>
@@ -6678,7 +6678,7 @@
               </a:spcAft>
             </a:pPr>
             <a:r>
-              <a:rPr sz="1350" b="0" i="0">
+              <a:rPr sz="1080" b="0" i="0">
                 <a:solidFill>
                   <a:srgbClr val="64748B"/>
                 </a:solidFill>

</xml_diff>